<commit_message>
PPTX: typeset formulas (LaTeX-rendered images) on slides 2, 4, 5
Co-Authored-By: Claude Opus 5.5 <noreply@anthropic.com>
</commit_message>
<xml_diff>
--- a/slides/paper15_team12_LouShu2017.pptx
+++ b/slides/paper15_team12_LouShu2017.pptx
@@ -7490,90 +7490,30 @@
           </a:p>
         </p:txBody>
       </p:sp>
-      <p:sp>
-        <p:nvSpPr>
-          <p:cNvPr id="7" name="TextBox 6"/>
-          <p:cNvSpPr txBox="1"/>
-          <p:nvPr/>
-        </p:nvSpPr>
-        <p:spPr>
-          <a:xfrm>
-            <a:off x="429768" y="2880360"/>
-            <a:ext cx="3840480" cy="457200"/>
-          </a:xfrm>
-          <a:prstGeom prst="rect">
-            <a:avLst/>
-          </a:prstGeom>
-          <a:noFill/>
-        </p:spPr>
-        <p:txBody>
-          <a:bodyPr wrap="square" lIns="0" rIns="0" tIns="0" bIns="0" anchor="t">
-            <a:spAutoFit/>
-          </a:bodyPr>
-          <a:lstStyle/>
-          <a:p>
-            <a:pPr algn="l">
-              <a:lnSpc>
-                <a:spcPct val="100000"/>
-              </a:lnSpc>
-            </a:pPr>
-            <a:r>
-              <a:rPr sz="1800" b="0" i="0">
-                <a:solidFill>
-                  <a:srgbClr val="0E2D69"/>
-                </a:solidFill>
-                <a:latin typeface="Arial"/>
-              </a:rPr>
-              <a:t>A = (1/D) · Σ</a:t>
-            </a:r>
-            <a:r>
-              <a:rPr sz="1800" b="0" i="0" baseline="-25000">
-                <a:solidFill>
-                  <a:srgbClr val="0E2D69"/>
-                </a:solidFill>
-                <a:latin typeface="Arial"/>
-              </a:rPr>
-              <a:t>d</a:t>
-            </a:r>
-            <a:r>
-              <a:rPr sz="1800" b="0" i="0">
-                <a:solidFill>
-                  <a:srgbClr val="0E2D69"/>
-                </a:solidFill>
-                <a:latin typeface="Arial"/>
-              </a:rPr>
-              <a:t> |r</a:t>
-            </a:r>
-            <a:r>
-              <a:rPr sz="1800" b="0" i="0" baseline="-25000">
-                <a:solidFill>
-                  <a:srgbClr val="0E2D69"/>
-                </a:solidFill>
-                <a:latin typeface="Arial"/>
-              </a:rPr>
-              <a:t>d</a:t>
-            </a:r>
-            <a:r>
-              <a:rPr sz="1800" b="0" i="0">
-                <a:solidFill>
-                  <a:srgbClr val="0E2D69"/>
-                </a:solidFill>
-                <a:latin typeface="Arial"/>
-              </a:rPr>
-              <a:t>| / DVol</a:t>
-            </a:r>
-            <a:r>
-              <a:rPr sz="1800" b="0" i="0" baseline="-25000">
-                <a:solidFill>
-                  <a:srgbClr val="0E2D69"/>
-                </a:solidFill>
-                <a:latin typeface="Arial"/>
-              </a:rPr>
-              <a:t>d</a:t>
-            </a:r>
-          </a:p>
-        </p:txBody>
-      </p:sp>
+      <p:pic>
+        <p:nvPicPr>
+          <p:cNvPr id="7" name="Picture 6" descr="amihud.png"/>
+          <p:cNvPicPr>
+            <a:picLocks noChangeAspect="1"/>
+          </p:cNvPicPr>
+          <p:nvPr/>
+        </p:nvPicPr>
+        <p:blipFill>
+          <a:blip r:embed="rId4"/>
+          <a:stretch>
+            <a:fillRect/>
+          </a:stretch>
+        </p:blipFill>
+        <p:spPr>
+          <a:xfrm>
+            <a:off x="429768" y="2697480"/>
+            <a:ext cx="1980590" cy="752856"/>
+          </a:xfrm>
+          <a:prstGeom prst="rect">
+            <a:avLst/>
+          </a:prstGeom>
+        </p:spPr>
+      </p:pic>
       <p:sp>
         <p:nvSpPr>
           <p:cNvPr id="8" name="TextBox 7"/>
@@ -8781,99 +8721,30 @@
           </a:p>
         </p:txBody>
       </p:sp>
-      <p:sp>
-        <p:nvSpPr>
-          <p:cNvPr id="6" name="TextBox 5"/>
-          <p:cNvSpPr txBox="1"/>
-          <p:nvPr/>
-        </p:nvSpPr>
-        <p:spPr>
-          <a:xfrm>
-            <a:off x="429768" y="1828800"/>
-            <a:ext cx="3840480" cy="457200"/>
-          </a:xfrm>
-          <a:prstGeom prst="rect">
-            <a:avLst/>
-          </a:prstGeom>
-          <a:noFill/>
-        </p:spPr>
-        <p:txBody>
-          <a:bodyPr wrap="square" lIns="0" rIns="0" tIns="0" bIns="0" anchor="t">
-            <a:spAutoFit/>
-          </a:bodyPr>
-          <a:lstStyle/>
-          <a:p>
-            <a:pPr algn="l">
-              <a:lnSpc>
-                <a:spcPct val="100000"/>
-              </a:lnSpc>
-            </a:pPr>
-            <a:r>
-              <a:rPr sz="1800" b="0" i="0">
-                <a:solidFill>
-                  <a:srgbClr val="0E2D69"/>
-                </a:solidFill>
-                <a:latin typeface="Arial"/>
-              </a:rPr>
-              <a:t>ln A = a</a:t>
-            </a:r>
-            <a:r>
-              <a:rPr sz="1800" b="0" i="0" baseline="-25000">
-                <a:solidFill>
-                  <a:srgbClr val="0E2D69"/>
-                </a:solidFill>
-                <a:latin typeface="Arial"/>
-              </a:rPr>
-              <a:t>t</a:t>
-            </a:r>
-            <a:r>
-              <a:rPr sz="1800" b="0" i="0">
-                <a:solidFill>
-                  <a:srgbClr val="0E2D69"/>
-                </a:solidFill>
-                <a:latin typeface="Arial"/>
-              </a:rPr>
-              <a:t> + b</a:t>
-            </a:r>
-            <a:r>
-              <a:rPr sz="1800" b="0" i="0" baseline="-25000">
-                <a:solidFill>
-                  <a:srgbClr val="0E2D69"/>
-                </a:solidFill>
-                <a:latin typeface="Arial"/>
-              </a:rPr>
-              <a:t>t</a:t>
-            </a:r>
-            <a:r>
-              <a:rPr sz="1800" b="0" i="0">
-                <a:solidFill>
-                  <a:srgbClr val="0E2D69"/>
-                </a:solidFill>
-                <a:latin typeface="Arial"/>
-              </a:rPr>
-              <a:t> · ln A</a:t>
-            </a:r>
-            <a:r>
-              <a:rPr sz="1800" b="0" i="0" baseline="-25000">
-                <a:solidFill>
-                  <a:srgbClr val="0E2D69"/>
-                </a:solidFill>
-                <a:latin typeface="Arial"/>
-              </a:rPr>
-              <a:t>C</a:t>
-            </a:r>
-            <a:r>
-              <a:rPr sz="1800" b="0" i="0">
-                <a:solidFill>
-                  <a:srgbClr val="0E2D69"/>
-                </a:solidFill>
-                <a:latin typeface="Arial"/>
-              </a:rPr>
-              <a:t> + Res.ln A</a:t>
-            </a:r>
-          </a:p>
-        </p:txBody>
-      </p:sp>
+      <p:pic>
+        <p:nvPicPr>
+          <p:cNvPr id="6" name="Picture 5" descr="split.png"/>
+          <p:cNvPicPr>
+            <a:picLocks noChangeAspect="1"/>
+          </p:cNvPicPr>
+          <p:nvPr/>
+        </p:nvPicPr>
+        <p:blipFill>
+          <a:blip r:embed="rId4"/>
+          <a:stretch>
+            <a:fillRect/>
+          </a:stretch>
+        </p:blipFill>
+        <p:spPr>
+          <a:xfrm>
+            <a:off x="429768" y="1847088"/>
+            <a:ext cx="3675888" cy="326957"/>
+          </a:xfrm>
+          <a:prstGeom prst="rect">
+            <a:avLst/>
+          </a:prstGeom>
+        </p:spPr>
+      </p:pic>
       <p:sp>
         <p:nvSpPr>
           <p:cNvPr id="7" name="TextBox 6"/>
@@ -9849,126 +9720,30 @@
           </a:p>
         </p:txBody>
       </p:sp>
-      <p:sp>
-        <p:nvSpPr>
-          <p:cNvPr id="12" name="TextBox 11"/>
-          <p:cNvSpPr txBox="1"/>
-          <p:nvPr/>
-        </p:nvSpPr>
-        <p:spPr>
-          <a:xfrm>
-            <a:off x="429768" y="2697480"/>
-            <a:ext cx="8284464" cy="457200"/>
-          </a:xfrm>
-          <a:prstGeom prst="rect">
-            <a:avLst/>
-          </a:prstGeom>
-          <a:noFill/>
-        </p:spPr>
-        <p:txBody>
-          <a:bodyPr wrap="square" lIns="0" rIns="0" tIns="0" bIns="0" anchor="t">
-            <a:spAutoFit/>
-          </a:bodyPr>
-          <a:lstStyle/>
-          <a:p>
-            <a:pPr algn="ctr">
-              <a:lnSpc>
-                <a:spcPct val="100000"/>
-              </a:lnSpc>
-            </a:pPr>
-            <a:r>
-              <a:rPr sz="2200" b="0" i="0">
-                <a:solidFill>
-                  <a:srgbClr val="0E2D69"/>
-                </a:solidFill>
-                <a:latin typeface="Arial"/>
-              </a:rPr>
-              <a:t>r</a:t>
-            </a:r>
-            <a:r>
-              <a:rPr sz="2200" b="0" i="0" baseline="-25000">
-                <a:solidFill>
-                  <a:srgbClr val="0E2D69"/>
-                </a:solidFill>
-                <a:latin typeface="Arial"/>
-              </a:rPr>
-              <a:t>i,t</a:t>
-            </a:r>
-            <a:r>
-              <a:rPr sz="2200" b="0" i="0">
-                <a:solidFill>
-                  <a:srgbClr val="0E2D69"/>
-                </a:solidFill>
-                <a:latin typeface="Arial"/>
-              </a:rPr>
-              <a:t> = γ</a:t>
-            </a:r>
-            <a:r>
-              <a:rPr sz="2200" b="0" i="0" baseline="-25000">
-                <a:solidFill>
-                  <a:srgbClr val="0E2D69"/>
-                </a:solidFill>
-                <a:latin typeface="Arial"/>
-              </a:rPr>
-              <a:t>0</a:t>
-            </a:r>
-            <a:r>
-              <a:rPr sz="2200" b="0" i="0">
-                <a:solidFill>
-                  <a:srgbClr val="0E2D69"/>
-                </a:solidFill>
-                <a:latin typeface="Arial"/>
-              </a:rPr>
-              <a:t> + γ</a:t>
-            </a:r>
-            <a:r>
-              <a:rPr sz="2200" b="0" i="0" baseline="-25000">
-                <a:solidFill>
-                  <a:srgbClr val="0E2D69"/>
-                </a:solidFill>
-                <a:latin typeface="Arial"/>
-              </a:rPr>
-              <a:t>1</a:t>
-            </a:r>
-            <a:r>
-              <a:rPr sz="2200" b="0" i="0">
-                <a:solidFill>
-                  <a:srgbClr val="0E2D69"/>
-                </a:solidFill>
-                <a:latin typeface="Arial"/>
-              </a:rPr>
-              <a:t> X</a:t>
-            </a:r>
-            <a:r>
-              <a:rPr sz="2200" b="0" i="0" baseline="-25000">
-                <a:solidFill>
-                  <a:srgbClr val="0E2D69"/>
-                </a:solidFill>
-                <a:latin typeface="Arial"/>
-              </a:rPr>
-              <a:t>i,t−2</a:t>
-            </a:r>
-            <a:r>
-              <a:rPr sz="2200" b="0" i="0">
-                <a:solidFill>
-                  <a:srgbClr val="0E2D69"/>
-                </a:solidFill>
-                <a:latin typeface="Arial"/>
-              </a:rPr>
-              <a:t> + controls + ε</a:t>
-            </a:r>
-            <a:r>
-              <a:rPr sz="2200" b="0" i="0" baseline="-25000">
-                <a:solidFill>
-                  <a:srgbClr val="0E2D69"/>
-                </a:solidFill>
-                <a:latin typeface="Arial"/>
-              </a:rPr>
-              <a:t>i,t</a:t>
-            </a:r>
-          </a:p>
-        </p:txBody>
-      </p:sp>
+      <p:pic>
+        <p:nvPicPr>
+          <p:cNvPr id="12" name="Picture 11" descr="fm.png"/>
+          <p:cNvPicPr>
+            <a:picLocks noChangeAspect="1"/>
+          </p:cNvPicPr>
+          <p:nvPr/>
+        </p:nvPicPr>
+        <p:blipFill>
+          <a:blip r:embed="rId4"/>
+          <a:stretch>
+            <a:fillRect/>
+          </a:stretch>
+        </p:blipFill>
+        <p:spPr>
+          <a:xfrm>
+            <a:off x="2630729" y="2697480"/>
+            <a:ext cx="3882542" cy="333203"/>
+          </a:xfrm>
+          <a:prstGeom prst="rect">
+            <a:avLst/>
+          </a:prstGeom>
+        </p:spPr>
+      </p:pic>
       <p:sp>
         <p:nvSpPr>
           <p:cNvPr id="13" name="TextBox 12"/>

</xml_diff>